<commit_message>
chore: update presentation and guide tags to 'Capstone | B.Tech CSE'
</commit_message>
<xml_diff>
--- a/AWEN_Final_Presentation_AF52.pptx
+++ b/AWEN_Final_Presentation_AF52.pptx
@@ -3153,7 +3153,7 @@
         <p:spPr>
           <a:xfrm>
             <a:off x="731520" y="548640"/>
-            <a:ext cx="4114800" cy="411480"/>
+            <a:ext cx="3108960" cy="411480"/>
           </a:xfrm>
           <a:prstGeom prst="rect">
             <a:avLst/>
@@ -3194,7 +3194,7 @@
               </a:defRPr>
             </a:pPr>
             <a:r>
-              <a:t>CAPSTONE FINAL VIVA | B.TECH CSE</a:t>
+              <a:t>CAPSTONE | B.TECH CSE</a:t>
             </a:r>
           </a:p>
         </p:txBody>

</xml_diff>

<commit_message>
docs(team): update member details, PIDs and mentorship with Diya Singh as project lead
- Synchronize team credentials with CaPsToNe_HaRdWaRe reference (PIDs EU1258014, EU1258058, EU1258019, EU1258011)
- Detail Diya Singh's overall leadership as Principal System Architect across full-stack, ML engine, and hardware integration
- Credit Project Guide Prof. Sachin Sase across README, project report, and presentation slide decks
- Update Slide 1 team accreditation in public/presentation/index.html and AWEN_Final_Presentation_AF52.pptx
</commit_message>
<xml_diff>
--- a/AWEN_Final_Presentation_AF52.pptx
+++ b/AWEN_Final_Presentation_AF52.pptx
@@ -3807,6 +3807,87 @@
             </a:pPr>
             <a:r>
               <a:t>Saved right on your own laptop in local SQLite. Zero biometric data leaves your machine.</a:t>
+            </a:r>
+          </a:p>
+        </p:txBody>
+      </p:sp>
+      <p:sp>
+        <p:nvSpPr>
+          <p:cNvPr id="17" name="Rectangle 16"/>
+          <p:cNvSpPr/>
+          <p:nvPr/>
+        </p:nvSpPr>
+        <p:spPr>
+          <a:xfrm>
+            <a:off x="731520" y="6236208"/>
+            <a:ext cx="10728655" cy="438912"/>
+          </a:xfrm>
+          <a:prstGeom prst="rect">
+            <a:avLst/>
+          </a:prstGeom>
+          <a:solidFill>
+            <a:srgbClr val="FFFFFF"/>
+          </a:solidFill>
+          <a:ln w="31750">
+            <a:solidFill>
+              <a:srgbClr val="111111"/>
+            </a:solidFill>
+          </a:ln>
+        </p:spPr>
+        <p:style>
+          <a:lnRef idx="1">
+            <a:schemeClr val="accent1"/>
+          </a:lnRef>
+          <a:fillRef idx="3">
+            <a:schemeClr val="accent1"/>
+          </a:fillRef>
+          <a:effectRef idx="2">
+            <a:schemeClr val="accent1"/>
+          </a:effectRef>
+          <a:fontRef idx="minor">
+            <a:schemeClr val="lt1"/>
+          </a:fontRef>
+        </p:style>
+        <p:txBody>
+          <a:bodyPr rtlCol="0" anchor="ctr"/>
+          <a:lstStyle/>
+          <a:p>
+            <a:pPr algn="ctr"/>
+          </a:p>
+        </p:txBody>
+      </p:sp>
+      <p:sp>
+        <p:nvSpPr>
+          <p:cNvPr id="18" name="TextBox 17"/>
+          <p:cNvSpPr txBox="1"/>
+          <p:nvPr/>
+        </p:nvSpPr>
+        <p:spPr>
+          <a:xfrm>
+            <a:off x="822960" y="6254496"/>
+            <a:ext cx="10545775" cy="402336"/>
+          </a:xfrm>
+          <a:prstGeom prst="rect">
+            <a:avLst/>
+          </a:prstGeom>
+          <a:noFill/>
+        </p:spPr>
+        <p:txBody>
+          <a:bodyPr wrap="square" tIns="25400" bIns="25400">
+            <a:spAutoFit/>
+          </a:bodyPr>
+          <a:lstStyle/>
+          <a:p>
+            <a:pPr>
+              <a:defRPr sz="950" b="1">
+                <a:solidFill>
+                  <a:srgbClr val="111111"/>
+                </a:solidFill>
+                <a:latin typeface="Arial"/>
+              </a:defRPr>
+            </a:pPr>
+            <a:r>
+              <a:t>TEAM AF52: Diya Singh (Lead &amp; System Architect · EU1258014), Parth Topale (EU1258058), Nishtha Lokhande (EU1258019), Swara Patil (EU1258011) | Guide: Prof. Sachin Sase</a:t>
             </a:r>
           </a:p>
         </p:txBody>

</xml_diff>